<commit_message>
Correct demo slide item to dental calculus detection
Third demo item was described generically as tooth recognition; it is
specifically dental calculus (tartar) detection in the dog's oral
cavity. Media slot renamed teeth.png -> tartar.png.

Co-Authored-By: Claude Opus 5 <noreply@anthropic.com>
Claude-Session: https://claude.ai/code/session_011K39BoLYU1DirzweNMNW3m
</commit_message>
<xml_diff>
--- a/转正述职/转正述职报告-朱业拓.pptx
+++ b/转正述职/转正述职报告-朱业拓.pptx
@@ -2361,7 +2361,7 @@
           <a:p>
             <a:r>
               <a:rPr lang="en-US" dirty="0"/>
-              <a:t>这一页配合现场演示：先放抓挠检测的实际效果，再演示标注平台的操作，最后展示牙齿识别。演示时长控制在 2 分钟内。</a:t>
+              <a:t>这一页配合现场演示：先放抓挠检测的实际效果，再演示标注平台的操作，最后展示口腔牙结石识别。演示时长控制在 2 分钟内。</a:t>
             </a:r>
             <a:endParaRPr lang="en-US" dirty="0"/>
           </a:p>
@@ -15994,7 +15994,7 @@
                 <a:ea typeface="Arial" pitchFamily="34" charset="-122"/>
                 <a:cs typeface="Arial" pitchFamily="34" charset="-120"/>
               </a:rPr>
-              <a:t>牙齿识别效果</a:t>
+              <a:t>口腔牙结石识别</a:t>
             </a:r>
             <a:endParaRPr lang="en-US" sz="1400" dirty="0"/>
           </a:p>
@@ -16036,7 +16036,7 @@
                 <a:ea typeface="Arial" pitchFamily="34" charset="-122"/>
                 <a:cs typeface="Arial" pitchFamily="34" charset="-120"/>
               </a:rPr>
-              <a:t>基于图像的犬只识别能力延伸，用于后续口腔健康相关方向的探索</a:t>
+              <a:t>基于图像识别犬只口腔牙齿的牙结石情况，为口腔健康评估提供基础能力</a:t>
             </a:r>
             <a:endParaRPr lang="en-US" sz="1050" dirty="0"/>
           </a:p>

</xml_diff>

<commit_message>
State the external deployment accurately
algo_service was packaged and handed to the backend engineer, who
deployed it externally; App -> backend -> algorithm now runs end to end.
Phrase it as a delivery + collaboration outcome rather than implying the
deployment config lives in the repo (it does not).

Co-Authored-By: Claude Opus 5 <noreply@anthropic.com>
Claude-Session: https://claude.ai/code/session_011K39BoLYU1DirzweNMNW3m
</commit_message>
<xml_diff>
--- a/转正述职/转正述职报告-朱业拓.pptx
+++ b/转正述职/转正述职报告-朱业拓.pptx
@@ -4938,7 +4938,7 @@
                 <a:ea typeface="Arial" pitchFamily="34" charset="-122"/>
                 <a:cs typeface="Arial" pitchFamily="34" charset="-120"/>
               </a:rPr>
-              <a:t>数据库架构调整（IMU 六轴迁移 TDengine）、服务联调、模型服务外网对接打通</a:t>
+              <a:t>数据库架构调整（IMU 六轴迁移 TDengine）；交付算法服务打包工程，后端完成外网部署，App → 后端 → 算法全链路跑通</a:t>
             </a:r>
             <a:endParaRPr lang="en-US" sz="1100" dirty="0"/>
           </a:p>
@@ -16817,7 +16817,7 @@
                 <a:ea typeface="Arial" pitchFamily="34" charset="-122"/>
                 <a:cs typeface="Arial" pitchFamily="34" charset="-120"/>
               </a:rPr>
-              <a:t>TDengine 时序库 + MySQL 按设备分表，全链路按用户本地时区切天</a:t>
+              <a:t>TDengine 时序库 + MySQL 按设备分表，按用户本地时区切天</a:t>
             </a:r>
             <a:endParaRPr lang="en-US" sz="1000" dirty="0"/>
           </a:p>
@@ -16841,7 +16841,31 @@
                 <a:ea typeface="Arial" pitchFamily="34" charset="-122"/>
                 <a:cs typeface="Arial" pitchFamily="34" charset="-120"/>
               </a:rPr>
-              <a:t>133 个单元测试 / 约 162 条用例，全部不依赖外部服务即可运行</a:t>
+              <a:t>133 个单元测试 / 约 162 条用例，不依赖外部服务即可运行</a:t>
+            </a:r>
+            <a:endParaRPr lang="en-US" sz="1000" dirty="0"/>
+          </a:p>
+          <a:p>
+            <a:pPr marL="342900" indent="-342900">
+              <a:lnSpc>
+                <a:spcPct val="112000"/>
+              </a:lnSpc>
+              <a:spcAft>
+                <a:spcPts val="500"/>
+              </a:spcAft>
+              <a:buSzPct val="100000"/>
+              <a:buChar char="•"/>
+            </a:pPr>
+            <a:r>
+              <a:rPr lang="en-US" sz="1000" dirty="0">
+                <a:solidFill>
+                  <a:srgbClr val="2B2340"/>
+                </a:solidFill>
+                <a:latin typeface="Arial" pitchFamily="34" charset="0"/>
+                <a:ea typeface="Arial" pitchFamily="34" charset="-122"/>
+                <a:cs typeface="Arial" pitchFamily="34" charset="-120"/>
+              </a:rPr>
+              <a:t>已交付后端并完成外网部署，App → 后端 → 算法全链路跑通</a:t>
             </a:r>
             <a:endParaRPr lang="en-US" sz="1000" dirty="0"/>
           </a:p>

</xml_diff>

<commit_message>
Wire up demo screenshots with aspect-preserving embedding
Screenshots have very different aspect ratios (1.9 vs 1.11), so cover-
cropping would cut content out. Fit each image inside its panel instead
and letterbox on the dark brand panel.

scratch.png cropped from the uploaded recording (camera panels plus the
annotated-segment table); tartar.png used as supplied. platform.png slot
still falls back to the live-demo panel until the skin tracking table
screenshot is added.

Co-Authored-By: Claude Opus 5 <noreply@anthropic.com>
Claude-Session: https://claude.ai/code/session_011K39BoLYU1DirzweNMNW3m
</commit_message>
<xml_diff>
--- a/转正述职/转正述职报告-朱业拓.pptx
+++ b/转正述职/转正述职报告-朱业拓.pptx
@@ -18588,87 +18588,33 @@
           <a:ln/>
         </p:spPr>
       </p:sp>
-      <p:sp>
-        <p:nvSpPr>
-          <p:cNvPr id="8" name="Text 5"/>
-          <p:cNvSpPr txBox="1"/>
-          <p:nvPr/>
-        </p:nvSpPr>
-        <p:spPr>
-          <a:xfrm>
-            <a:off x="749808" y="2596896"/>
-            <a:ext cx="3172968" cy="548640"/>
-          </a:xfrm>
-          <a:prstGeom prst="rect">
-            <a:avLst/>
-          </a:prstGeom>
-          <a:noFill/>
-          <a:ln/>
-        </p:spPr>
-        <p:txBody>
-          <a:bodyPr wrap="square" lIns="0" tIns="0" rIns="0" bIns="0" rtlCol="0" anchor="ctr"/>
-          <a:lstStyle/>
-          <a:p>
-            <a:pPr algn="ctr" indent="0" marL="0">
-              <a:buNone/>
-            </a:pPr>
-            <a:r>
-              <a:rPr lang="en-US" sz="2800" b="1" dirty="0">
-                <a:solidFill>
-                  <a:srgbClr val="FCC279"/>
-                </a:solidFill>
-                <a:latin typeface="Arial" pitchFamily="34" charset="0"/>
-                <a:ea typeface="Arial" pitchFamily="34" charset="-122"/>
-                <a:cs typeface="Arial" pitchFamily="34" charset="-120"/>
-              </a:rPr>
-              <a:t>▶</a:t>
-            </a:r>
-            <a:endParaRPr lang="en-US" sz="2800" dirty="0"/>
-          </a:p>
-        </p:txBody>
-      </p:sp>
-      <p:sp>
-        <p:nvSpPr>
-          <p:cNvPr id="9" name="Text 6"/>
-          <p:cNvSpPr txBox="1"/>
-          <p:nvPr/>
-        </p:nvSpPr>
-        <p:spPr>
-          <a:xfrm>
-            <a:off x="749808" y="3163824"/>
-            <a:ext cx="3172968" cy="292608"/>
-          </a:xfrm>
-          <a:prstGeom prst="rect">
-            <a:avLst/>
-          </a:prstGeom>
-          <a:noFill/>
-          <a:ln/>
-        </p:spPr>
-        <p:txBody>
-          <a:bodyPr wrap="square" lIns="0" tIns="0" rIns="0" bIns="0" rtlCol="0" anchor="ctr"/>
-          <a:lstStyle/>
-          <a:p>
-            <a:pPr algn="ctr" indent="0" marL="0">
-              <a:buNone/>
-            </a:pPr>
-            <a:r>
-              <a:rPr lang="en-US" sz="1200" b="1" dirty="0">
-                <a:solidFill>
-                  <a:srgbClr val="FFFFFF"/>
-                </a:solidFill>
-                <a:latin typeface="Arial" pitchFamily="34" charset="0"/>
-                <a:ea typeface="Arial" pitchFamily="34" charset="-122"/>
-                <a:cs typeface="Arial" pitchFamily="34" charset="-120"/>
-              </a:rPr>
-              <a:t>现场演示</a:t>
-            </a:r>
-            <a:endParaRPr lang="en-US" sz="1200" dirty="0"/>
-          </a:p>
-        </p:txBody>
-      </p:sp>
-      <p:sp>
-        <p:nvSpPr>
-          <p:cNvPr id="10" name="Text 7"/>
+      <p:pic>
+        <p:nvPicPr>
+          <p:cNvPr id="8" name="Image 1" descr="media/scratch.png">    </p:cNvPr>
+          <p:cNvPicPr>
+            <a:picLocks noChangeAspect="1"/>
+          </p:cNvPicPr>
+          <p:nvPr/>
+        </p:nvPicPr>
+        <p:blipFill>
+          <a:blip r:embed="rId2"/>
+          <a:stretch>
+            <a:fillRect/>
+          </a:stretch>
+        </p:blipFill>
+        <p:spPr>
+          <a:xfrm>
+            <a:off x="749808" y="2174685"/>
+            <a:ext cx="3172968" cy="1667381"/>
+          </a:xfrm>
+          <a:prstGeom prst="rect">
+            <a:avLst/>
+          </a:prstGeom>
+        </p:spPr>
+      </p:pic>
+      <p:sp>
+        <p:nvSpPr>
+          <p:cNvPr id="9" name="Text 5"/>
           <p:cNvSpPr txBox="1"/>
           <p:nvPr/>
         </p:nvSpPr>
@@ -18699,7 +18645,7 @@
                 <a:ea typeface="Arial" pitchFamily="34" charset="-122"/>
                 <a:cs typeface="Arial" pitchFamily="34" charset="-120"/>
               </a:rPr>
-              <a:t>抓挠检测效果</a:t>
+              <a:t>抓挠检出与人工确认</a:t>
             </a:r>
             <a:endParaRPr lang="en-US" sz="1400" dirty="0"/>
           </a:p>
@@ -18707,7 +18653,7 @@
       </p:sp>
       <p:sp>
         <p:nvSpPr>
-          <p:cNvPr id="11" name="Text 8"/>
+          <p:cNvPr id="10" name="Text 6"/>
           <p:cNvSpPr txBox="1"/>
           <p:nvPr/>
         </p:nvSpPr>
@@ -18741,7 +18687,7 @@
                 <a:ea typeface="Arial" pitchFamily="34" charset="-122"/>
                 <a:cs typeface="Arial" pitchFamily="34" charset="-120"/>
               </a:rPr>
-              <a:t>IMU 信号实时推理，视频与识别结果同步比对，可直观看到抓挠片段的检出</a:t>
+              <a:t>三路画面同步回看，模型预标片段标注置信度 88%，疑似片段 37% 单独列出待确认</a:t>
             </a:r>
             <a:endParaRPr lang="en-US" sz="1050" dirty="0"/>
           </a:p>
@@ -18749,7 +18695,7 @@
       </p:sp>
       <p:sp>
         <p:nvSpPr>
-          <p:cNvPr id="12" name="Shape 9"/>
+          <p:cNvPr id="11" name="Shape 7"/>
           <p:cNvSpPr/>
           <p:nvPr/>
         </p:nvSpPr>
@@ -18771,7 +18717,7 @@
       </p:sp>
       <p:sp>
         <p:nvSpPr>
-          <p:cNvPr id="13" name="Shape 10"/>
+          <p:cNvPr id="12" name="Shape 8"/>
           <p:cNvSpPr/>
           <p:nvPr/>
         </p:nvSpPr>
@@ -18793,7 +18739,7 @@
       </p:sp>
       <p:sp>
         <p:nvSpPr>
-          <p:cNvPr id="14" name="Text 11"/>
+          <p:cNvPr id="13" name="Text 9"/>
           <p:cNvSpPr txBox="1"/>
           <p:nvPr/>
         </p:nvSpPr>
@@ -18832,7 +18778,7 @@
       </p:sp>
       <p:sp>
         <p:nvSpPr>
-          <p:cNvPr id="15" name="Text 12"/>
+          <p:cNvPr id="14" name="Text 10"/>
           <p:cNvSpPr txBox="1"/>
           <p:nvPr/>
         </p:nvSpPr>
@@ -18871,7 +18817,7 @@
       </p:sp>
       <p:sp>
         <p:nvSpPr>
-          <p:cNvPr id="16" name="Text 13"/>
+          <p:cNvPr id="15" name="Text 11"/>
           <p:cNvSpPr txBox="1"/>
           <p:nvPr/>
         </p:nvSpPr>
@@ -18902,7 +18848,7 @@
                 <a:ea typeface="Arial" pitchFamily="34" charset="-122"/>
                 <a:cs typeface="Arial" pitchFamily="34" charset="-120"/>
               </a:rPr>
-              <a:t>数据标注平台</a:t>
+              <a:t>皮肤评估每日跟踪</a:t>
             </a:r>
             <a:endParaRPr lang="en-US" sz="1400" dirty="0"/>
           </a:p>
@@ -18910,7 +18856,7 @@
       </p:sp>
       <p:sp>
         <p:nvSpPr>
-          <p:cNvPr id="17" name="Text 14"/>
+          <p:cNvPr id="16" name="Text 12"/>
           <p:cNvSpPr txBox="1"/>
           <p:nvPr/>
         </p:nvSpPr>
@@ -18944,7 +18890,7 @@
                 <a:ea typeface="Arial" pitchFamily="34" charset="-122"/>
                 <a:cs typeface="Arial" pitchFamily="34" charset="-120"/>
               </a:rPr>
-              <a:t>NAS 数据挂载、成员分级权限、视频标注流畅度优化后的实际操作界面</a:t>
+              <a:t>每犬每日自动跑出有效佩戴、抓挠统计、C 值与 S 总分，AI 版与人工版并列对比</a:t>
             </a:r>
             <a:endParaRPr lang="en-US" sz="1050" dirty="0"/>
           </a:p>
@@ -18952,7 +18898,7 @@
       </p:sp>
       <p:sp>
         <p:nvSpPr>
-          <p:cNvPr id="18" name="Shape 15"/>
+          <p:cNvPr id="17" name="Shape 13"/>
           <p:cNvSpPr/>
           <p:nvPr/>
         </p:nvSpPr>
@@ -18974,7 +18920,7 @@
       </p:sp>
       <p:sp>
         <p:nvSpPr>
-          <p:cNvPr id="19" name="Shape 16"/>
+          <p:cNvPr id="18" name="Shape 14"/>
           <p:cNvSpPr/>
           <p:nvPr/>
         </p:nvSpPr>
@@ -18994,87 +18940,33 @@
           <a:ln/>
         </p:spPr>
       </p:sp>
-      <p:sp>
-        <p:nvSpPr>
-          <p:cNvPr id="20" name="Text 17"/>
-          <p:cNvSpPr txBox="1"/>
-          <p:nvPr/>
-        </p:nvSpPr>
-        <p:spPr>
-          <a:xfrm>
-            <a:off x="8266176" y="2596896"/>
-            <a:ext cx="3172968" cy="548640"/>
-          </a:xfrm>
-          <a:prstGeom prst="rect">
-            <a:avLst/>
-          </a:prstGeom>
-          <a:noFill/>
-          <a:ln/>
-        </p:spPr>
-        <p:txBody>
-          <a:bodyPr wrap="square" lIns="0" tIns="0" rIns="0" bIns="0" rtlCol="0" anchor="ctr"/>
-          <a:lstStyle/>
-          <a:p>
-            <a:pPr algn="ctr" indent="0" marL="0">
-              <a:buNone/>
-            </a:pPr>
-            <a:r>
-              <a:rPr lang="en-US" sz="2800" b="1" dirty="0">
-                <a:solidFill>
-                  <a:srgbClr val="FCC279"/>
-                </a:solidFill>
-                <a:latin typeface="Arial" pitchFamily="34" charset="0"/>
-                <a:ea typeface="Arial" pitchFamily="34" charset="-122"/>
-                <a:cs typeface="Arial" pitchFamily="34" charset="-120"/>
-              </a:rPr>
-              <a:t>▶</a:t>
-            </a:r>
-            <a:endParaRPr lang="en-US" sz="2800" dirty="0"/>
-          </a:p>
-        </p:txBody>
-      </p:sp>
-      <p:sp>
-        <p:nvSpPr>
-          <p:cNvPr id="21" name="Text 18"/>
-          <p:cNvSpPr txBox="1"/>
-          <p:nvPr/>
-        </p:nvSpPr>
-        <p:spPr>
-          <a:xfrm>
-            <a:off x="8266176" y="3163824"/>
-            <a:ext cx="3172968" cy="292608"/>
-          </a:xfrm>
-          <a:prstGeom prst="rect">
-            <a:avLst/>
-          </a:prstGeom>
-          <a:noFill/>
-          <a:ln/>
-        </p:spPr>
-        <p:txBody>
-          <a:bodyPr wrap="square" lIns="0" tIns="0" rIns="0" bIns="0" rtlCol="0" anchor="ctr"/>
-          <a:lstStyle/>
-          <a:p>
-            <a:pPr algn="ctr" indent="0" marL="0">
-              <a:buNone/>
-            </a:pPr>
-            <a:r>
-              <a:rPr lang="en-US" sz="1200" b="1" dirty="0">
-                <a:solidFill>
-                  <a:srgbClr val="FFFFFF"/>
-                </a:solidFill>
-                <a:latin typeface="Arial" pitchFamily="34" charset="0"/>
-                <a:ea typeface="Arial" pitchFamily="34" charset="-122"/>
-                <a:cs typeface="Arial" pitchFamily="34" charset="-120"/>
-              </a:rPr>
-              <a:t>现场演示</a:t>
-            </a:r>
-            <a:endParaRPr lang="en-US" sz="1200" dirty="0"/>
-          </a:p>
-        </p:txBody>
-      </p:sp>
-      <p:sp>
-        <p:nvSpPr>
-          <p:cNvPr id="22" name="Text 19"/>
+      <p:pic>
+        <p:nvPicPr>
+          <p:cNvPr id="19" name="Image 2" descr="media/tartar.png">    </p:cNvPr>
+          <p:cNvPicPr>
+            <a:picLocks noChangeAspect="1"/>
+          </p:cNvPicPr>
+          <p:nvPr/>
+        </p:nvPicPr>
+        <p:blipFill>
+          <a:blip r:embed="rId3"/>
+          <a:stretch>
+            <a:fillRect/>
+          </a:stretch>
+        </p:blipFill>
+        <p:spPr>
+          <a:xfrm>
+            <a:off x="8664656" y="1938528"/>
+            <a:ext cx="2376008" cy="2139696"/>
+          </a:xfrm>
+          <a:prstGeom prst="rect">
+            <a:avLst/>
+          </a:prstGeom>
+        </p:spPr>
+      </p:pic>
+      <p:sp>
+        <p:nvSpPr>
+          <p:cNvPr id="20" name="Text 15"/>
           <p:cNvSpPr txBox="1"/>
           <p:nvPr/>
         </p:nvSpPr>
@@ -19105,7 +18997,7 @@
                 <a:ea typeface="Arial" pitchFamily="34" charset="-122"/>
                 <a:cs typeface="Arial" pitchFamily="34" charset="-120"/>
               </a:rPr>
-              <a:t>口腔牙结石识别</a:t>
+              <a:t>口腔牙齿检测</a:t>
             </a:r>
             <a:endParaRPr lang="en-US" sz="1400" dirty="0"/>
           </a:p>
@@ -19113,7 +19005,7 @@
       </p:sp>
       <p:sp>
         <p:nvSpPr>
-          <p:cNvPr id="23" name="Text 20"/>
+          <p:cNvPr id="21" name="Text 16"/>
           <p:cNvSpPr txBox="1"/>
           <p:nvPr/>
         </p:nvSpPr>
@@ -19147,7 +19039,7 @@
                 <a:ea typeface="Arial" pitchFamily="34" charset="-122"/>
                 <a:cs typeface="Arial" pitchFamily="34" charset="-120"/>
               </a:rPr>
-              <a:t>基于图像识别犬只口腔牙齿的牙结石情况，为口腔健康评估提供基础能力</a:t>
+              <a:t>图片 / 视频 / 摄像头实时三种模式，正常与异常识别置信度 0.91 / 0.92</a:t>
             </a:r>
             <a:endParaRPr lang="en-US" sz="1050" dirty="0"/>
           </a:p>
@@ -19155,7 +19047,7 @@
       </p:sp>
       <p:sp>
         <p:nvSpPr>
-          <p:cNvPr id="24" name="Text 21"/>
+          <p:cNvPr id="22" name="Text 17"/>
           <p:cNvSpPr txBox="1"/>
           <p:nvPr/>
         </p:nvSpPr>

</xml_diff>

<commit_message>
Embed the skin tracking screenshot; demo page complete
All three demo slots now carry real screenshots.

Co-Authored-By: Claude Opus 5 <noreply@anthropic.com>
Claude-Session: https://claude.ai/code/session_011K39BoLYU1DirzweNMNW3m
</commit_message>
<xml_diff>
--- a/转正述职/转正述职报告-朱业拓.pptx
+++ b/转正述职/转正述职报告-朱业拓.pptx
@@ -18737,212 +18737,9 @@
           <a:ln/>
         </p:spPr>
       </p:sp>
-      <p:sp>
-        <p:nvSpPr>
-          <p:cNvPr id="13" name="Text 9"/>
-          <p:cNvSpPr txBox="1"/>
-          <p:nvPr/>
-        </p:nvSpPr>
-        <p:spPr>
-          <a:xfrm>
-            <a:off x="4507992" y="2596896"/>
-            <a:ext cx="3172968" cy="548640"/>
-          </a:xfrm>
-          <a:prstGeom prst="rect">
-            <a:avLst/>
-          </a:prstGeom>
-          <a:noFill/>
-          <a:ln/>
-        </p:spPr>
-        <p:txBody>
-          <a:bodyPr wrap="square" lIns="0" tIns="0" rIns="0" bIns="0" rtlCol="0" anchor="ctr"/>
-          <a:lstStyle/>
-          <a:p>
-            <a:pPr algn="ctr" indent="0" marL="0">
-              <a:buNone/>
-            </a:pPr>
-            <a:r>
-              <a:rPr lang="en-US" sz="2800" b="1" dirty="0">
-                <a:solidFill>
-                  <a:srgbClr val="FCC279"/>
-                </a:solidFill>
-                <a:latin typeface="Arial" pitchFamily="34" charset="0"/>
-                <a:ea typeface="Arial" pitchFamily="34" charset="-122"/>
-                <a:cs typeface="Arial" pitchFamily="34" charset="-120"/>
-              </a:rPr>
-              <a:t>▶</a:t>
-            </a:r>
-            <a:endParaRPr lang="en-US" sz="2800" dirty="0"/>
-          </a:p>
-        </p:txBody>
-      </p:sp>
-      <p:sp>
-        <p:nvSpPr>
-          <p:cNvPr id="14" name="Text 10"/>
-          <p:cNvSpPr txBox="1"/>
-          <p:nvPr/>
-        </p:nvSpPr>
-        <p:spPr>
-          <a:xfrm>
-            <a:off x="4507992" y="3163824"/>
-            <a:ext cx="3172968" cy="292608"/>
-          </a:xfrm>
-          <a:prstGeom prst="rect">
-            <a:avLst/>
-          </a:prstGeom>
-          <a:noFill/>
-          <a:ln/>
-        </p:spPr>
-        <p:txBody>
-          <a:bodyPr wrap="square" lIns="0" tIns="0" rIns="0" bIns="0" rtlCol="0" anchor="ctr"/>
-          <a:lstStyle/>
-          <a:p>
-            <a:pPr algn="ctr" indent="0" marL="0">
-              <a:buNone/>
-            </a:pPr>
-            <a:r>
-              <a:rPr lang="en-US" sz="1200" b="1" dirty="0">
-                <a:solidFill>
-                  <a:srgbClr val="FFFFFF"/>
-                </a:solidFill>
-                <a:latin typeface="Arial" pitchFamily="34" charset="0"/>
-                <a:ea typeface="Arial" pitchFamily="34" charset="-122"/>
-                <a:cs typeface="Arial" pitchFamily="34" charset="-120"/>
-              </a:rPr>
-              <a:t>现场演示</a:t>
-            </a:r>
-            <a:endParaRPr lang="en-US" sz="1200" dirty="0"/>
-          </a:p>
-        </p:txBody>
-      </p:sp>
-      <p:sp>
-        <p:nvSpPr>
-          <p:cNvPr id="15" name="Text 11"/>
-          <p:cNvSpPr txBox="1"/>
-          <p:nvPr/>
-        </p:nvSpPr>
-        <p:spPr>
-          <a:xfrm>
-            <a:off x="4526280" y="4224528"/>
-            <a:ext cx="3145536" cy="310896"/>
-          </a:xfrm>
-          <a:prstGeom prst="rect">
-            <a:avLst/>
-          </a:prstGeom>
-          <a:noFill/>
-          <a:ln/>
-        </p:spPr>
-        <p:txBody>
-          <a:bodyPr wrap="square" lIns="0" tIns="0" rIns="0" bIns="0" rtlCol="0" anchor="ctr"/>
-          <a:lstStyle/>
-          <a:p>
-            <a:pPr indent="0" marL="0">
-              <a:buNone/>
-            </a:pPr>
-            <a:r>
-              <a:rPr lang="en-US" sz="1400" b="1" dirty="0">
-                <a:solidFill>
-                  <a:srgbClr val="452D8D"/>
-                </a:solidFill>
-                <a:latin typeface="Arial" pitchFamily="34" charset="0"/>
-                <a:ea typeface="Arial" pitchFamily="34" charset="-122"/>
-                <a:cs typeface="Arial" pitchFamily="34" charset="-120"/>
-              </a:rPr>
-              <a:t>皮肤评估每日跟踪</a:t>
-            </a:r>
-            <a:endParaRPr lang="en-US" sz="1400" dirty="0"/>
-          </a:p>
-        </p:txBody>
-      </p:sp>
-      <p:sp>
-        <p:nvSpPr>
-          <p:cNvPr id="16" name="Text 12"/>
-          <p:cNvSpPr txBox="1"/>
-          <p:nvPr/>
-        </p:nvSpPr>
-        <p:spPr>
-          <a:xfrm>
-            <a:off x="4526280" y="4608576"/>
-            <a:ext cx="3145536" cy="1097280"/>
-          </a:xfrm>
-          <a:prstGeom prst="rect">
-            <a:avLst/>
-          </a:prstGeom>
-          <a:noFill/>
-          <a:ln/>
-        </p:spPr>
-        <p:txBody>
-          <a:bodyPr wrap="square" lIns="0" tIns="0" rIns="0" bIns="0" rtlCol="0" anchor="t"/>
-          <a:lstStyle/>
-          <a:p>
-            <a:pPr indent="0" marL="0">
-              <a:lnSpc>
-                <a:spcPct val="130000"/>
-              </a:lnSpc>
-              <a:buNone/>
-            </a:pPr>
-            <a:r>
-              <a:rPr lang="en-US" sz="1050" dirty="0">
-                <a:solidFill>
-                  <a:srgbClr val="2B2340"/>
-                </a:solidFill>
-                <a:latin typeface="Arial" pitchFamily="34" charset="0"/>
-                <a:ea typeface="Arial" pitchFamily="34" charset="-122"/>
-                <a:cs typeface="Arial" pitchFamily="34" charset="-120"/>
-              </a:rPr>
-              <a:t>每犬每日自动跑出有效佩戴、抓挠统计、C 值与 S 总分，AI 版与人工版并列对比</a:t>
-            </a:r>
-            <a:endParaRPr lang="en-US" sz="1050" dirty="0"/>
-          </a:p>
-        </p:txBody>
-      </p:sp>
-      <p:sp>
-        <p:nvSpPr>
-          <p:cNvPr id="17" name="Shape 13"/>
-          <p:cNvSpPr/>
-          <p:nvPr/>
-        </p:nvSpPr>
-        <p:spPr>
-          <a:xfrm>
-            <a:off x="8065008" y="1737360"/>
-            <a:ext cx="3575304" cy="4206240"/>
-          </a:xfrm>
-          <a:prstGeom prst="roundRect">
-            <a:avLst>
-              <a:gd name="adj" fmla="val 2558"/>
-            </a:avLst>
-          </a:prstGeom>
-          <a:solidFill>
-            <a:srgbClr val="F3F1FF"/>
-          </a:solidFill>
-          <a:ln/>
-        </p:spPr>
-      </p:sp>
-      <p:sp>
-        <p:nvSpPr>
-          <p:cNvPr id="18" name="Shape 14"/>
-          <p:cNvSpPr/>
-          <p:nvPr/>
-        </p:nvSpPr>
-        <p:spPr>
-          <a:xfrm>
-            <a:off x="8266176" y="1938528"/>
-            <a:ext cx="3172968" cy="2139696"/>
-          </a:xfrm>
-          <a:prstGeom prst="roundRect">
-            <a:avLst>
-              <a:gd name="adj" fmla="val 3419"/>
-            </a:avLst>
-          </a:prstGeom>
-          <a:solidFill>
-            <a:srgbClr val="452D8D"/>
-          </a:solidFill>
-          <a:ln/>
-        </p:spPr>
-      </p:sp>
       <p:pic>
         <p:nvPicPr>
-          <p:cNvPr id="19" name="Image 2" descr="media/tartar.png">    </p:cNvPr>
+          <p:cNvPr id="13" name="Image 2" descr="media/platform.png">    </p:cNvPr>
           <p:cNvPicPr>
             <a:picLocks noChangeAspect="1"/>
           </p:cNvPicPr>
@@ -18956,8 +18753,8 @@
         </p:blipFill>
         <p:spPr>
           <a:xfrm>
-            <a:off x="8664656" y="1938528"/>
-            <a:ext cx="2376008" cy="2139696"/>
+            <a:off x="4507992" y="2255622"/>
+            <a:ext cx="3172968" cy="1505507"/>
           </a:xfrm>
           <a:prstGeom prst="rect">
             <a:avLst/>
@@ -18966,13 +18763,13 @@
       </p:pic>
       <p:sp>
         <p:nvSpPr>
-          <p:cNvPr id="20" name="Text 15"/>
-          <p:cNvSpPr txBox="1"/>
-          <p:nvPr/>
-        </p:nvSpPr>
-        <p:spPr>
-          <a:xfrm>
-            <a:off x="8284464" y="4224528"/>
+          <p:cNvPr id="14" name="Text 9"/>
+          <p:cNvSpPr txBox="1"/>
+          <p:nvPr/>
+        </p:nvSpPr>
+        <p:spPr>
+          <a:xfrm>
+            <a:off x="4526280" y="4224528"/>
             <a:ext cx="3145536" cy="310896"/>
           </a:xfrm>
           <a:prstGeom prst="rect">
@@ -18997,7 +18794,7 @@
                 <a:ea typeface="Arial" pitchFamily="34" charset="-122"/>
                 <a:cs typeface="Arial" pitchFamily="34" charset="-120"/>
               </a:rPr>
-              <a:t>口腔牙齿检测</a:t>
+              <a:t>皮肤评估每日跟踪</a:t>
             </a:r>
             <a:endParaRPr lang="en-US" sz="1400" dirty="0"/>
           </a:p>
@@ -19005,13 +18802,13 @@
       </p:sp>
       <p:sp>
         <p:nvSpPr>
-          <p:cNvPr id="21" name="Text 16"/>
-          <p:cNvSpPr txBox="1"/>
-          <p:nvPr/>
-        </p:nvSpPr>
-        <p:spPr>
-          <a:xfrm>
-            <a:off x="8284464" y="4608576"/>
+          <p:cNvPr id="15" name="Text 10"/>
+          <p:cNvSpPr txBox="1"/>
+          <p:nvPr/>
+        </p:nvSpPr>
+        <p:spPr>
+          <a:xfrm>
+            <a:off x="4526280" y="4608576"/>
             <a:ext cx="3145536" cy="1097280"/>
           </a:xfrm>
           <a:prstGeom prst="rect">
@@ -19039,6 +18836,155 @@
                 <a:ea typeface="Arial" pitchFamily="34" charset="-122"/>
                 <a:cs typeface="Arial" pitchFamily="34" charset="-120"/>
               </a:rPr>
+              <a:t>每犬每日自动跑出有效佩戴、抓挠统计、C 值与 S 总分，AI 版与人工版并列对比</a:t>
+            </a:r>
+            <a:endParaRPr lang="en-US" sz="1050" dirty="0"/>
+          </a:p>
+        </p:txBody>
+      </p:sp>
+      <p:sp>
+        <p:nvSpPr>
+          <p:cNvPr id="16" name="Shape 11"/>
+          <p:cNvSpPr/>
+          <p:nvPr/>
+        </p:nvSpPr>
+        <p:spPr>
+          <a:xfrm>
+            <a:off x="8065008" y="1737360"/>
+            <a:ext cx="3575304" cy="4206240"/>
+          </a:xfrm>
+          <a:prstGeom prst="roundRect">
+            <a:avLst>
+              <a:gd name="adj" fmla="val 2558"/>
+            </a:avLst>
+          </a:prstGeom>
+          <a:solidFill>
+            <a:srgbClr val="F3F1FF"/>
+          </a:solidFill>
+          <a:ln/>
+        </p:spPr>
+      </p:sp>
+      <p:sp>
+        <p:nvSpPr>
+          <p:cNvPr id="17" name="Shape 12"/>
+          <p:cNvSpPr/>
+          <p:nvPr/>
+        </p:nvSpPr>
+        <p:spPr>
+          <a:xfrm>
+            <a:off x="8266176" y="1938528"/>
+            <a:ext cx="3172968" cy="2139696"/>
+          </a:xfrm>
+          <a:prstGeom prst="roundRect">
+            <a:avLst>
+              <a:gd name="adj" fmla="val 3419"/>
+            </a:avLst>
+          </a:prstGeom>
+          <a:solidFill>
+            <a:srgbClr val="452D8D"/>
+          </a:solidFill>
+          <a:ln/>
+        </p:spPr>
+      </p:sp>
+      <p:pic>
+        <p:nvPicPr>
+          <p:cNvPr id="18" name="Image 3" descr="media/tartar.png">    </p:cNvPr>
+          <p:cNvPicPr>
+            <a:picLocks noChangeAspect="1"/>
+          </p:cNvPicPr>
+          <p:nvPr/>
+        </p:nvPicPr>
+        <p:blipFill>
+          <a:blip r:embed="rId4"/>
+          <a:stretch>
+            <a:fillRect/>
+          </a:stretch>
+        </p:blipFill>
+        <p:spPr>
+          <a:xfrm>
+            <a:off x="8664656" y="1938528"/>
+            <a:ext cx="2376008" cy="2139696"/>
+          </a:xfrm>
+          <a:prstGeom prst="rect">
+            <a:avLst/>
+          </a:prstGeom>
+        </p:spPr>
+      </p:pic>
+      <p:sp>
+        <p:nvSpPr>
+          <p:cNvPr id="19" name="Text 13"/>
+          <p:cNvSpPr txBox="1"/>
+          <p:nvPr/>
+        </p:nvSpPr>
+        <p:spPr>
+          <a:xfrm>
+            <a:off x="8284464" y="4224528"/>
+            <a:ext cx="3145536" cy="310896"/>
+          </a:xfrm>
+          <a:prstGeom prst="rect">
+            <a:avLst/>
+          </a:prstGeom>
+          <a:noFill/>
+          <a:ln/>
+        </p:spPr>
+        <p:txBody>
+          <a:bodyPr wrap="square" lIns="0" tIns="0" rIns="0" bIns="0" rtlCol="0" anchor="ctr"/>
+          <a:lstStyle/>
+          <a:p>
+            <a:pPr indent="0" marL="0">
+              <a:buNone/>
+            </a:pPr>
+            <a:r>
+              <a:rPr lang="en-US" sz="1400" b="1" dirty="0">
+                <a:solidFill>
+                  <a:srgbClr val="452D8D"/>
+                </a:solidFill>
+                <a:latin typeface="Arial" pitchFamily="34" charset="0"/>
+                <a:ea typeface="Arial" pitchFamily="34" charset="-122"/>
+                <a:cs typeface="Arial" pitchFamily="34" charset="-120"/>
+              </a:rPr>
+              <a:t>口腔牙齿检测</a:t>
+            </a:r>
+            <a:endParaRPr lang="en-US" sz="1400" dirty="0"/>
+          </a:p>
+        </p:txBody>
+      </p:sp>
+      <p:sp>
+        <p:nvSpPr>
+          <p:cNvPr id="20" name="Text 14"/>
+          <p:cNvSpPr txBox="1"/>
+          <p:nvPr/>
+        </p:nvSpPr>
+        <p:spPr>
+          <a:xfrm>
+            <a:off x="8284464" y="4608576"/>
+            <a:ext cx="3145536" cy="1097280"/>
+          </a:xfrm>
+          <a:prstGeom prst="rect">
+            <a:avLst/>
+          </a:prstGeom>
+          <a:noFill/>
+          <a:ln/>
+        </p:spPr>
+        <p:txBody>
+          <a:bodyPr wrap="square" lIns="0" tIns="0" rIns="0" bIns="0" rtlCol="0" anchor="t"/>
+          <a:lstStyle/>
+          <a:p>
+            <a:pPr indent="0" marL="0">
+              <a:lnSpc>
+                <a:spcPct val="130000"/>
+              </a:lnSpc>
+              <a:buNone/>
+            </a:pPr>
+            <a:r>
+              <a:rPr lang="en-US" sz="1050" dirty="0">
+                <a:solidFill>
+                  <a:srgbClr val="2B2340"/>
+                </a:solidFill>
+                <a:latin typeface="Arial" pitchFamily="34" charset="0"/>
+                <a:ea typeface="Arial" pitchFamily="34" charset="-122"/>
+                <a:cs typeface="Arial" pitchFamily="34" charset="-120"/>
+              </a:rPr>
               <a:t>图片 / 视频 / 摄像头实时三种模式，正常与异常识别置信度 0.91 / 0.92</a:t>
             </a:r>
             <a:endParaRPr lang="en-US" sz="1050" dirty="0"/>
@@ -19047,7 +18993,7 @@
       </p:sp>
       <p:sp>
         <p:nvSpPr>
-          <p:cNvPr id="22" name="Text 17"/>
+          <p:cNvPr id="21" name="Text 15"/>
           <p:cNvSpPr txBox="1"/>
           <p:nvPr/>
         </p:nvSpPr>

</xml_diff>